<commit_message>
Name Dr. Sumit Kumar as Head of Department in BDA submissions.
Co-authored-by: dhingrasukhada <dhingrasukhada@gmail.com>
</commit_message>
<xml_diff>
--- a/BDA_Project_Presentation_2026_2027.pptx
+++ b/BDA_Project_Presentation_2026_2027.pptx
@@ -3722,8 +3722,43 @@
         </p:nvSpPr>
         <p:spPr>
           <a:xfrm>
-            <a:off x="640080" y="3520440"/>
-            <a:ext cx="7315200" cy="2011680"/>
+            <a:off x="640080" y="3200400"/>
+            <a:ext cx="10972800" cy="320040"/>
+          </a:xfrm>
+          <a:prstGeom prst="rect">
+            <a:avLst/>
+          </a:prstGeom>
+          <a:noFill/>
+        </p:spPr>
+        <p:txBody>
+          <a:bodyPr wrap="square">
+            <a:spAutoFit/>
+          </a:bodyPr>
+          <a:lstStyle/>
+          <a:p>
+            <a:pPr algn="l"/>
+            <a:r>
+              <a:rPr sz="1400" b="0">
+                <a:solidFill>
+                  <a:srgbClr val="5A9E7A"/>
+                </a:solidFill>
+                <a:latin typeface="Calibri"/>
+              </a:rPr>
+              <a:t>Head of the Department: Dr. Sumit Kumar</a:t>
+            </a:r>
+          </a:p>
+        </p:txBody>
+      </p:sp>
+      <p:sp>
+        <p:nvSpPr>
+          <p:cNvPr id="9" name="TextBox 8"/>
+          <p:cNvSpPr txBox="1"/>
+          <p:nvPr/>
+        </p:nvSpPr>
+        <p:spPr>
+          <a:xfrm>
+            <a:off x="640080" y="3703320"/>
+            <a:ext cx="7315200" cy="1828800"/>
           </a:xfrm>
           <a:prstGeom prst="rect">
             <a:avLst/>
@@ -3814,7 +3849,7 @@
       </p:sp>
       <p:sp>
         <p:nvSpPr>
-          <p:cNvPr id="9" name="TextBox 8"/>
+          <p:cNvPr id="10" name="TextBox 9"/>
           <p:cNvSpPr txBox="1"/>
           <p:nvPr/>
         </p:nvSpPr>
@@ -5508,8 +5543,8 @@
         </p:nvSpPr>
         <p:spPr>
           <a:xfrm>
-            <a:off x="640080" y="5669280"/>
-            <a:ext cx="10972800" cy="365760"/>
+            <a:off x="640080" y="5349240"/>
+            <a:ext cx="10972800" cy="320040"/>
           </a:xfrm>
           <a:prstGeom prst="rect">
             <a:avLst/>
@@ -5530,7 +5565,42 @@
                 </a:solidFill>
                 <a:latin typeface="Calibri"/>
               </a:rPr>
-              <a:t>Guide: Dr. Archana Choudary  ·  BDA 0701260704  ·  SIT AIML  ·  AY 2026–2027</a:t>
+              <a:t>Guide: Dr. Archana Choudary  ·  Head of the Department: Dr. Sumit Kumar</a:t>
+            </a:r>
+          </a:p>
+        </p:txBody>
+      </p:sp>
+      <p:sp>
+        <p:nvSpPr>
+          <p:cNvPr id="8" name="TextBox 7"/>
+          <p:cNvSpPr txBox="1"/>
+          <p:nvPr/>
+        </p:nvSpPr>
+        <p:spPr>
+          <a:xfrm>
+            <a:off x="640080" y="5715000"/>
+            <a:ext cx="10972800" cy="320040"/>
+          </a:xfrm>
+          <a:prstGeom prst="rect">
+            <a:avLst/>
+          </a:prstGeom>
+          <a:noFill/>
+        </p:spPr>
+        <p:txBody>
+          <a:bodyPr wrap="square">
+            <a:spAutoFit/>
+          </a:bodyPr>
+          <a:lstStyle/>
+          <a:p>
+            <a:pPr algn="ctr"/>
+            <a:r>
+              <a:rPr sz="1200" b="0">
+                <a:solidFill>
+                  <a:srgbClr val="5A9E7A"/>
+                </a:solidFill>
+                <a:latin typeface="Calibri"/>
+              </a:rPr>
+              <a:t>BDA 0701260704  ·  SIT AIML  ·  AY 2026–2027</a:t>
             </a:r>
           </a:p>
         </p:txBody>

</xml_diff>